<commit_message>
Update Zeroth review- Real-Time Voice AI Agent for Banking Support & Legal Research Assistant for Indian Courts.pptx
</commit_message>
<xml_diff>
--- a/Zeroth review- Real-Time Voice AI Agent for Banking Support & Legal Research Assistant for Indian Courts.pptx
+++ b/Zeroth review- Real-Time Voice AI Agent for Banking Support & Legal Research Assistant for Indian Courts.pptx
@@ -3758,11 +3758,32 @@
         </p:spPr>
         <p:txBody>
           <a:bodyPr anchor="ctr">
-            <a:normAutofit/>
+            <a:normAutofit fontScale="90000"/>
           </a:bodyPr>
           <a:lstStyle/>
           <a:p>
             <a:pPr algn="r"/>
+            <a:r>
+              <a:rPr lang="en-US" sz="5600" dirty="0">
+                <a:solidFill>
+                  <a:schemeClr val="tx1">
+                    <a:lumMod val="75000"/>
+                    <a:lumOff val="25000"/>
+                  </a:schemeClr>
+                </a:solidFill>
+              </a:rPr>
+              <a:t>Zeroth Review:</a:t>
+            </a:r>
+            <a:br>
+              <a:rPr lang="en-US" sz="5600" dirty="0">
+                <a:solidFill>
+                  <a:schemeClr val="tx1">
+                    <a:lumMod val="75000"/>
+                    <a:lumOff val="25000"/>
+                  </a:schemeClr>
+                </a:solidFill>
+              </a:rPr>
+            </a:br>
             <a:r>
               <a:rPr lang="en-US" sz="5600" dirty="0">
                 <a:solidFill>

</xml_diff>